<commit_message>
Rename 'pillar' -> 'layer' (Visibility/Control/Governance are layers)
Across code (LAYERS, LAYER_BY_ID, layer field, _layers_covered), frontend,
tests, README, docs, the runbook .docx, and the PDF + screen-deck generators
(regenerated dist/ + docs/ assets). 18 tests pass.

Co-Authored-By: Claude Opus 4.8 <noreply@anthropic.com>
Claude-Session: https://claude.ai/code/session_015ZWvrFYVoFJWbwDM3Jvb31
</commit_message>
<xml_diff>
--- a/dist/AI4_VisionOne_Challenge_BoothScreen.pptx
+++ b/dist/AI4_VisionOne_Challenge_BoothScreen.pptx
@@ -3409,7 +3409,7 @@
                 </a:solidFill>
                 <a:latin typeface="Arial"/>
               </a:rPr>
-              <a:t>•  Earn a stamp in each pillar — Visibility · Control · Governance.</a:t>
+              <a:t>•  Earn a stamp in each layer — Visibility · Control · Governance.</a:t>
             </a:r>
           </a:p>
           <a:p>
@@ -3441,7 +3441,7 @@
                 </a:solidFill>
                 <a:latin typeface="Arial"/>
               </a:rPr>
-              <a:t>•  One challenge per pillar fills your passport and enters the grand-prize draw.</a:t>
+              <a:t>•  One challenge per layer fills your passport and enters the grand-prize draw.</a:t>
             </a:r>
           </a:p>
         </p:txBody>
@@ -3611,7 +3611,7 @@
                           </a:solidFill>
                           <a:latin typeface="Arial"/>
                         </a:rPr>
-                        <a:t>Pillar</a:t>
+                        <a:t>Layer</a:t>
                       </a:r>
                     </a:p>
                   </a:txBody>
@@ -4843,7 +4843,7 @@
                 </a:solidFill>
                 <a:latin typeface="Arial"/>
               </a:rPr>
-              <a:t>•  Full passport (one per pillar) → premium swag + grand-prize draw.</a:t>
+              <a:t>•  Full passport (one per layer) → premium swag + grand-prize draw.</a:t>
             </a:r>
           </a:p>
           <a:p>

</xml_diff>